<commit_message>
Correct Kyrgyz spelling and teacher notes in lesson decks.
Edit slide and notes text runs only: spelling, thousands separators,
decimal commas, ирээт, окуучу, and shorter teacher instructions.
Migration 0050 rewrites a volume file only when its hash is still the
pre-correction bytes and the result matches the manifest.

Co-authored-by: Amanov <isaamanov@gmail.com>
</commit_message>
<xml_diff>
--- a/apps/resources/bundled_files/3-klass-bolchok-tushunugu-oyun-1234.pptx
+++ b/apps/resources/bundled_files/3-klass-bolchok-tushunugu-oyun-1234.pptx
@@ -15686,7 +15686,7 @@
                 </a:solidFill>
                 <a:latin typeface="PT Sans"/>
               </a:rPr>
-              <a:t>Нан 4 бирдей бөлүк, 3ү жейилди. Калганы?</a:t>
+              <a:t>Нан 4 бирдей бөлүк, 3ү желди. Калганы?</a:t>
             </a:r>
           </a:p>
         </p:txBody>
@@ -17681,7 +17681,7 @@
                 </a:solidFill>
                 <a:latin typeface="PT Sans"/>
               </a:rPr>
-              <a:t>Нан 4 бирдей бөлүк, 3ү жейилди. Калганы?</a:t>
+              <a:t>Нан 4 бирдей бөлүк, 3ү желди. Калганы?</a:t>
             </a:r>
           </a:p>
         </p:txBody>

</xml_diff>

<commit_message>
Correct Kyrgyz spelling and teacher notes in lesson decks (#39)
* Correct lesson-deck spelling, grade chips and leftover English

Edit the text inside existing slides only. A data-only migration rewrites
a file on the media volume when its hash is still the old deck.

Co-authored-by: Amanov <isaamanov@gmail.com>

* Correct Kyrgyz spelling and teacher notes in lesson decks.

Edit slide and notes text runs only: spelling, thousands separators,
decimal commas, ирээт, окуучу, and shorter teacher instructions.
Migration 0050 rewrites a volume file only when its hash is still the
pre-correction bytes and the result matches the manifest.

Co-authored-by: Amanov <isaamanov@gmail.com>

---------

Co-authored-by: Cursor Agent <cursoragent@cursor.com>
</commit_message>
<xml_diff>
--- a/apps/resources/bundled_files/3-klass-bolchok-tushunugu-oyun-1234.pptx
+++ b/apps/resources/bundled_files/3-klass-bolchok-tushunugu-oyun-1234.pptx
@@ -15686,7 +15686,7 @@
                 </a:solidFill>
                 <a:latin typeface="PT Sans"/>
               </a:rPr>
-              <a:t>Нан 4 бирдей бөлүк, 3ү жейилди. Калганы?</a:t>
+              <a:t>Нан 4 бирдей бөлүк, 3ү желди. Калганы?</a:t>
             </a:r>
           </a:p>
         </p:txBody>
@@ -17681,7 +17681,7 @@
                 </a:solidFill>
                 <a:latin typeface="PT Sans"/>
               </a:rPr>
-              <a:t>Нан 4 бирдей бөлүк, 3ү жейилди. Калганы?</a:t>
+              <a:t>Нан 4 бирдей бөлүк, 3ү желди. Калганы?</a:t>
             </a:r>
           </a:p>
         </p:txBody>

</xml_diff>